<commit_message>
Deploy protected TA Guide 2026-09-10 14:19 CDT
</commit_message>
<xml_diff>
--- a/lab-materials/lab03/files/lab03_reading_slides.pptx
+++ b/lab-materials/lab03/files/lab03_reading_slides.pptx
@@ -2028,13 +2028,41 @@
         </p:nvSpPr>
         <p:spPr>
           <a:xfrm>
-            <a:off x="1581912" y="2638044"/>
-            <a:ext cx="4271771" cy="3101982"/>
+            <a:off x="1097280" y="2638044"/>
+            <a:ext cx="4907280" cy="3465576"/>
           </a:xfrm>
         </p:spPr>
         <p:txBody>
           <a:bodyPr/>
-          <a:lstStyle/>
+          <a:lstStyle>
+            <a:lvl1pPr>
+              <a:defRPr sz="2000"/>
+            </a:lvl1pPr>
+            <a:lvl2pPr>
+              <a:defRPr sz="2000"/>
+            </a:lvl2pPr>
+            <a:lvl3pPr>
+              <a:defRPr sz="2000"/>
+            </a:lvl3pPr>
+            <a:lvl4pPr>
+              <a:defRPr sz="2000"/>
+            </a:lvl4pPr>
+            <a:lvl5pPr>
+              <a:defRPr sz="2000"/>
+            </a:lvl5pPr>
+            <a:lvl6pPr>
+              <a:defRPr sz="2000"/>
+            </a:lvl6pPr>
+            <a:lvl7pPr>
+              <a:defRPr sz="2000"/>
+            </a:lvl7pPr>
+            <a:lvl8pPr>
+              <a:defRPr sz="2000"/>
+            </a:lvl8pPr>
+            <a:lvl9pPr>
+              <a:defRPr sz="2000"/>
+            </a:lvl9pPr>
+          </a:lstStyle>
           <a:p>
             <a:pPr lvl="0"/>
             <a:r>
@@ -2085,13 +2113,41 @@
         </p:nvSpPr>
         <p:spPr>
           <a:xfrm>
-            <a:off x="6338315" y="2638044"/>
-            <a:ext cx="4270247" cy="3101982"/>
+            <a:off x="6187440" y="2638044"/>
+            <a:ext cx="4907280" cy="3465576"/>
           </a:xfrm>
         </p:spPr>
         <p:txBody>
           <a:bodyPr/>
-          <a:lstStyle/>
+          <a:lstStyle>
+            <a:lvl1pPr>
+              <a:defRPr sz="2000"/>
+            </a:lvl1pPr>
+            <a:lvl2pPr>
+              <a:defRPr sz="2000"/>
+            </a:lvl2pPr>
+            <a:lvl3pPr>
+              <a:defRPr sz="2000"/>
+            </a:lvl3pPr>
+            <a:lvl4pPr>
+              <a:defRPr sz="2000"/>
+            </a:lvl4pPr>
+            <a:lvl5pPr>
+              <a:defRPr sz="2000"/>
+            </a:lvl5pPr>
+            <a:lvl6pPr>
+              <a:defRPr sz="2000"/>
+            </a:lvl6pPr>
+            <a:lvl7pPr>
+              <a:defRPr sz="2000"/>
+            </a:lvl7pPr>
+            <a:lvl8pPr>
+              <a:defRPr sz="2000"/>
+            </a:lvl8pPr>
+            <a:lvl9pPr>
+              <a:defRPr sz="2000"/>
+            </a:lvl9pPr>
+          </a:lstStyle>
           <a:p>
             <a:pPr lvl="0"/>
             <a:r>
@@ -2232,8 +2288,8 @@
         </p:nvSpPr>
         <p:spPr>
           <a:xfrm>
-            <a:off x="1583436" y="2313433"/>
-            <a:ext cx="4270248" cy="704087"/>
+            <a:off x="1097280" y="2313433"/>
+            <a:ext cx="4907280" cy="548640"/>
           </a:xfrm>
         </p:spPr>
         <p:txBody>
@@ -2243,7 +2299,7 @@
           <a:lstStyle>
             <a:lvl1pPr marL="0" indent="0" algn="ctr">
               <a:buNone/>
-              <a:defRPr sz="1900" b="0" cap="all" spc="100" baseline="0">
+              <a:defRPr sz="2200" b="0" cap="all" spc="100" baseline="0">
                 <a:solidFill>
                   <a:schemeClr val="accent2">
                     <a:lumMod val="75000"/>
@@ -2253,35 +2309,35 @@
             </a:lvl1pPr>
             <a:lvl2pPr marL="457200" indent="0">
               <a:buNone/>
-              <a:defRPr sz="1900" b="1"/>
+              <a:defRPr sz="2200" b="1"/>
             </a:lvl2pPr>
             <a:lvl3pPr marL="914400" indent="0">
               <a:buNone/>
-              <a:defRPr sz="1800" b="1"/>
+              <a:defRPr sz="2200" b="1"/>
             </a:lvl3pPr>
             <a:lvl4pPr marL="1371600" indent="0">
               <a:buNone/>
-              <a:defRPr sz="1600" b="1"/>
+              <a:defRPr sz="2200" b="1"/>
             </a:lvl4pPr>
             <a:lvl5pPr marL="1828800" indent="0">
               <a:buNone/>
-              <a:defRPr sz="1600" b="1"/>
+              <a:defRPr sz="2200" b="1"/>
             </a:lvl5pPr>
             <a:lvl6pPr marL="2286000" indent="0">
               <a:buNone/>
-              <a:defRPr sz="1600" b="1"/>
+              <a:defRPr sz="2200" b="1"/>
             </a:lvl6pPr>
             <a:lvl7pPr marL="2743200" indent="0">
               <a:buNone/>
-              <a:defRPr sz="1600" b="1"/>
+              <a:defRPr sz="2200" b="1"/>
             </a:lvl7pPr>
             <a:lvl8pPr marL="3200400" indent="0">
               <a:buNone/>
-              <a:defRPr sz="1600" b="1"/>
+              <a:defRPr sz="2200" b="1"/>
             </a:lvl8pPr>
             <a:lvl9pPr marL="3657600" indent="0">
               <a:buNone/>
-              <a:defRPr sz="1600" b="1"/>
+              <a:defRPr sz="2200" b="1"/>
             </a:lvl9pPr>
           </a:lstStyle>
           <a:p>
@@ -2305,13 +2361,41 @@
         </p:nvSpPr>
         <p:spPr>
           <a:xfrm>
-            <a:off x="1583436" y="3143250"/>
-            <a:ext cx="4270248" cy="2596776"/>
+            <a:off x="1097280" y="2926080"/>
+            <a:ext cx="4907280" cy="3177540"/>
           </a:xfrm>
         </p:spPr>
         <p:txBody>
           <a:bodyPr/>
-          <a:lstStyle/>
+          <a:lstStyle>
+            <a:lvl1pPr>
+              <a:defRPr sz="2000"/>
+            </a:lvl1pPr>
+            <a:lvl2pPr>
+              <a:defRPr sz="2000"/>
+            </a:lvl2pPr>
+            <a:lvl3pPr>
+              <a:defRPr sz="2000"/>
+            </a:lvl3pPr>
+            <a:lvl4pPr>
+              <a:defRPr sz="2000"/>
+            </a:lvl4pPr>
+            <a:lvl5pPr>
+              <a:defRPr sz="2000"/>
+            </a:lvl5pPr>
+            <a:lvl6pPr>
+              <a:defRPr sz="2000"/>
+            </a:lvl6pPr>
+            <a:lvl7pPr>
+              <a:defRPr sz="2000"/>
+            </a:lvl7pPr>
+            <a:lvl8pPr>
+              <a:defRPr sz="2000"/>
+            </a:lvl8pPr>
+            <a:lvl9pPr>
+              <a:defRPr sz="2000"/>
+            </a:lvl9pPr>
+          </a:lstStyle>
           <a:p>
             <a:pPr lvl="0"/>
             <a:r>
@@ -2362,16 +2446,40 @@
         </p:nvSpPr>
         <p:spPr>
           <a:xfrm>
-            <a:off x="6338316" y="3143250"/>
-            <a:ext cx="4253484" cy="2596776"/>
+            <a:off x="6187440" y="2926080"/>
+            <a:ext cx="4907280" cy="3177540"/>
           </a:xfrm>
         </p:spPr>
         <p:txBody>
           <a:bodyPr/>
           <a:lstStyle>
             <a:lvl5pPr>
-              <a:defRPr/>
+              <a:defRPr sz="2000"/>
             </a:lvl5pPr>
+            <a:lvl1pPr>
+              <a:defRPr sz="2000"/>
+            </a:lvl1pPr>
+            <a:lvl2pPr>
+              <a:defRPr sz="2000"/>
+            </a:lvl2pPr>
+            <a:lvl3pPr>
+              <a:defRPr sz="2000"/>
+            </a:lvl3pPr>
+            <a:lvl4pPr>
+              <a:defRPr sz="2000"/>
+            </a:lvl4pPr>
+            <a:lvl6pPr>
+              <a:defRPr sz="2000"/>
+            </a:lvl6pPr>
+            <a:lvl7pPr>
+              <a:defRPr sz="2000"/>
+            </a:lvl7pPr>
+            <a:lvl8pPr>
+              <a:defRPr sz="2000"/>
+            </a:lvl8pPr>
+            <a:lvl9pPr>
+              <a:defRPr sz="2000"/>
+            </a:lvl9pPr>
           </a:lstStyle>
           <a:p>
             <a:pPr lvl="0"/>
@@ -2423,8 +2531,8 @@
         </p:nvSpPr>
         <p:spPr>
           <a:xfrm>
-            <a:off x="6338316" y="2313433"/>
-            <a:ext cx="4270248" cy="704087"/>
+            <a:off x="6187440" y="2313433"/>
+            <a:ext cx="4907280" cy="548640"/>
           </a:xfrm>
         </p:spPr>
         <p:txBody>
@@ -2434,7 +2542,7 @@
           <a:lstStyle>
             <a:lvl1pPr marL="0" indent="0" algn="ctr">
               <a:buNone/>
-              <a:defRPr sz="1900" b="0" cap="all" spc="100" baseline="0">
+              <a:defRPr sz="2200" b="0" cap="all" spc="100" baseline="0">
                 <a:solidFill>
                   <a:schemeClr val="accent2">
                     <a:lumMod val="75000"/>
@@ -2444,35 +2552,35 @@
             </a:lvl1pPr>
             <a:lvl2pPr marL="457200" indent="0">
               <a:buNone/>
-              <a:defRPr sz="1900" b="1"/>
+              <a:defRPr sz="2200" b="1"/>
             </a:lvl2pPr>
             <a:lvl3pPr marL="914400" indent="0">
               <a:buNone/>
-              <a:defRPr sz="1800" b="1"/>
+              <a:defRPr sz="2200" b="1"/>
             </a:lvl3pPr>
             <a:lvl4pPr marL="1371600" indent="0">
               <a:buNone/>
-              <a:defRPr sz="1600" b="1"/>
+              <a:defRPr sz="2200" b="1"/>
             </a:lvl4pPr>
             <a:lvl5pPr marL="1828800" indent="0">
               <a:buNone/>
-              <a:defRPr sz="1600" b="1"/>
+              <a:defRPr sz="2200" b="1"/>
             </a:lvl5pPr>
             <a:lvl6pPr marL="2286000" indent="0">
               <a:buNone/>
-              <a:defRPr sz="1600" b="1"/>
+              <a:defRPr sz="2200" b="1"/>
             </a:lvl6pPr>
             <a:lvl7pPr marL="2743200" indent="0">
               <a:buNone/>
-              <a:defRPr sz="1600" b="1"/>
+              <a:defRPr sz="2200" b="1"/>
             </a:lvl7pPr>
             <a:lvl8pPr marL="3200400" indent="0">
               <a:buNone/>
-              <a:defRPr sz="1600" b="1"/>
+              <a:defRPr sz="2200" b="1"/>
             </a:lvl8pPr>
             <a:lvl9pPr marL="3657600" indent="0">
               <a:buNone/>
-              <a:defRPr sz="1600" b="1"/>
+              <a:defRPr sz="2200" b="1"/>
             </a:lvl9pPr>
           </a:lstStyle>
           <a:p>
@@ -2559,7 +2667,12 @@
             <p:ph type="title"/>
           </p:nvPr>
         </p:nvSpPr>
-        <p:spPr/>
+        <p:spPr>
+          <a:xfrm>
+            <a:off x="1097280" y="964692"/>
+            <a:ext cx="9997440" cy="1188720"/>
+          </a:xfrm>
+        </p:spPr>
         <p:txBody>
           <a:bodyPr/>
           <a:lstStyle/>
@@ -4705,20 +4818,20 @@
       </p:sp>
       <p:graphicFrame xmlns:a="http://schemas.openxmlformats.org/drawingml/2006/main" xmlns:r="http://schemas.openxmlformats.org/officeDocument/2006/relationships" xmlns:p="http://schemas.openxmlformats.org/presentationml/2006/main">
         <p:nvGraphicFramePr>
-          <p:cNvPr id="729723705" name=""/>
+          <p:cNvPr id="714578376" name=""/>
           <p:cNvGraphicFramePr>
             <a:graphicFrameLocks noGrp="true"/>
           </p:cNvGraphicFramePr>
           <p:nvPr/>
         </p:nvGraphicFramePr>
-        <p:xfrm rot="0">
-          <a:off x="914400" y="1828800"/>
-          <a:ext cx="9144000" cy="5486400"/>
+        <p:xfrm>
+          <a:off x="2438400" y="3108960"/>
+          <a:ext cx="7315200" cy="1828800"/>
         </p:xfrm>
         <a:graphic>
           <a:graphicData uri="http://schemas.openxmlformats.org/drawingml/2006/table">
             <a:tbl>
-              <a:tblPr/>
+              <a:tblPr firstRow="1"/>
               <a:tblGrid>
                 <a:gridCol w="1828800"/>
                 <a:gridCol w="5486400"/>
@@ -6102,20 +6215,20 @@
       </p:sp>
       <p:graphicFrame xmlns:a="http://schemas.openxmlformats.org/drawingml/2006/main" xmlns:r="http://schemas.openxmlformats.org/officeDocument/2006/relationships" xmlns:p="http://schemas.openxmlformats.org/presentationml/2006/main">
         <p:nvGraphicFramePr>
-          <p:cNvPr id="456311802" name=""/>
+          <p:cNvPr id="689573992" name=""/>
           <p:cNvGraphicFramePr>
             <a:graphicFrameLocks noGrp="true"/>
           </p:cNvGraphicFramePr>
           <p:nvPr/>
         </p:nvGraphicFramePr>
-        <p:xfrm rot="0">
-          <a:off x="914400" y="1828800"/>
-          <a:ext cx="9144000" cy="5486400"/>
+        <p:xfrm>
+          <a:off x="2438400" y="3108960"/>
+          <a:ext cx="7315200" cy="2057400"/>
         </p:xfrm>
         <a:graphic>
           <a:graphicData uri="http://schemas.openxmlformats.org/drawingml/2006/table">
             <a:tbl>
-              <a:tblPr/>
+              <a:tblPr firstRow="1"/>
               <a:tblGrid>
                 <a:gridCol w="4023360"/>
                 <a:gridCol w="3291840"/>

</xml_diff>